<commit_message>
m8 - fixing typos
</commit_message>
<xml_diff>
--- a/Slides/Module 08 Concurrency.pptx
+++ b/Slides/Module 08 Concurrency.pptx
@@ -3060,15 +3060,7 @@
             </a:r>
             <a:r>
               <a:rPr lang="en-US" b="0" dirty="0"/>
-              <a:t> checks to make sure that your test properly awaited the </a:t>
-            </a:r>
-            <a:r>
-              <a:rPr lang="en-US" b="0" dirty="0" err="1"/>
-              <a:t>the</a:t>
-            </a:r>
-            <a:r>
-              <a:rPr lang="en-US" b="0" dirty="0"/>
-              <a:t> result of the request.</a:t>
+              <a:t> checks to make sure that your test properly awaited the result of the request.</a:t>
             </a:r>
             <a:endParaRPr lang="en-US" dirty="0"/>
           </a:p>
@@ -3097,32 +3089,7 @@
           <a:p>
             <a:r>
               <a:rPr lang="en-US" dirty="0"/>
-              <a:t>Here, </a:t>
-            </a:r>
-            <a:r>
-              <a:rPr lang="en-US" b="1" dirty="0"/>
-              <a:t>echo</a:t>
-            </a:r>
-            <a:r>
-              <a:rPr lang="en-US" dirty="0"/>
-              <a:t> is an async function, so it returns a promise, which should eventually return a string (here “33”) to the async function that called it (here, the </a:t>
-            </a:r>
-            <a:r>
-              <a:rPr lang="en-US" b="1" dirty="0"/>
-              <a:t>expect</a:t>
-            </a:r>
-            <a:r>
-              <a:rPr lang="en-US" dirty="0"/>
-              <a:t>).  So here we are saying that we expect echo(33) to return a promise that will eventually resolve to “33”.</a:t>
-            </a:r>
-          </a:p>
-          <a:p>
-            <a:endParaRPr lang="en-US" dirty="0"/>
-          </a:p>
-          <a:p>
-            <a:r>
-              <a:rPr lang="en-US" dirty="0"/>
-              <a:t>Note the await on the next to last line.  If you leave that out, the async function in the test will succeed immediately, without waiting for the expect to run.   The </a:t>
+              <a:t>The </a:t>
             </a:r>
             <a:r>
               <a:rPr lang="en-US" b="1" dirty="0" err="1"/>
@@ -3134,7 +3101,15 @@
             </a:r>
             <a:r>
               <a:rPr lang="en-US" dirty="0"/>
-              <a:t>(in blue) tells Jest that the test should run exactly 1 test, so that will make the test fail if you leave out the </a:t>
+              <a:t>(in blue) tells </a:t>
+            </a:r>
+            <a:r>
+              <a:rPr lang="en-US" dirty="0" err="1"/>
+              <a:t>Vitest</a:t>
+            </a:r>
+            <a:r>
+              <a:rPr lang="en-US" dirty="0"/>
+              <a:t> that the test should run exactly 1 expect statement, so that will make the test fail if you leave out the </a:t>
             </a:r>
             <a:r>
               <a:rPr lang="en-US" b="1" dirty="0"/>
@@ -3206,14 +3181,24 @@
           <a:p>
             <a:r>
               <a:rPr lang="en-US" dirty="0"/>
-              <a:t>We've already seen non-deterministic behavior reflected in our console logs.  But that kind of behavior can easily become visible to our program.  All you need is some shared state across your promises. The activity explores this topic in more depth.</a:t>
-            </a:r>
-          </a:p>
-          <a:p>
-            <a:endParaRPr lang="en-US" dirty="0"/>
-          </a:p>
-          <a:p>
-            <a:endParaRPr lang="en-US" dirty="0"/>
+              <a:t>We've already seen non-deterministic behavior reflected in our console logs.  But that kind of behavior can easily become visible to our program. All you need is some shared state across your promises. </a:t>
+            </a:r>
+            <a:br>
+              <a:rPr lang="en-US" dirty="0"/>
+            </a:br>
+            <a:r>
+              <a:rPr lang="en-US" dirty="0"/>
+              <a:t>In the code above, X and Y are run concurrently (4 times) and depending on which functions finishes first, X or Y is pushed to log first.</a:t>
+            </a:r>
+          </a:p>
+          <a:p>
+            <a:br>
+              <a:rPr lang="en-US" dirty="0"/>
+            </a:br>
+            <a:r>
+              <a:rPr lang="en-US" dirty="0"/>
+              <a:t>The activity explores this topic in more depth.</a:t>
+            </a:r>
           </a:p>
         </p:txBody>
       </p:sp>
@@ -3292,6 +3277,39 @@
           <a:bodyPr/>
           <a:lstStyle/>
           <a:p>
+            <a:r>
+              <a:rPr lang="en-US" dirty="0"/>
+              <a:t>IO operations are async functions that return promises and you can await on them.</a:t>
+            </a:r>
+          </a:p>
+          <a:p>
+            <a:endParaRPr lang="en-US" dirty="0"/>
+          </a:p>
+          <a:p>
+            <a:r>
+              <a:rPr lang="en-US" dirty="0"/>
+              <a:t>Using </a:t>
+            </a:r>
+            <a:r>
+              <a:rPr lang="en-US" dirty="0" err="1"/>
+              <a:t>WebAPI</a:t>
+            </a:r>
+            <a:r>
+              <a:rPr lang="en-US" dirty="0"/>
+              <a:t> is like outsourcing of jobs. </a:t>
+            </a:r>
+            <a:r>
+              <a:rPr lang="en-US" dirty="0" err="1"/>
+              <a:t>WebAPI</a:t>
+            </a:r>
+            <a:r>
+              <a:rPr lang="en-US" dirty="0"/>
+              <a:t> uses browser to run these jobs and browser can run things using </a:t>
+            </a:r>
+            <a:r>
+              <a:rPr lang="en-US"/>
+              <a:t>multiple threads.</a:t>
+            </a:r>
             <a:endParaRPr lang="en-US" dirty="0"/>
           </a:p>
         </p:txBody>
@@ -4515,7 +4533,7 @@
                 <a:tabLst/>
                 <a:defRPr/>
               </a:pPr>
-              <a:t>9/30/2026</a:t>
+              <a:t>10/4/2026</a:t>
             </a:fld>
             <a:endParaRPr kumimoji="0" lang="en-US" sz="1200" b="0" i="0" u="none" strike="noStrike" kern="1200" cap="none" spc="0" normalizeH="0" baseline="0" noProof="0">
               <a:ln>
@@ -4999,7 +5017,7 @@
                 <a:tabLst/>
                 <a:defRPr/>
               </a:pPr>
-              <a:t>9/30/2026</a:t>
+              <a:t>10/4/2026</a:t>
             </a:fld>
             <a:endParaRPr kumimoji="0" lang="en-US" sz="1200" b="0" i="0" u="none" strike="noStrike" kern="1200" cap="none" spc="0" normalizeH="0" baseline="0" noProof="0">
               <a:ln>
@@ -5357,7 +5375,7 @@
                 <a:tabLst/>
                 <a:defRPr/>
               </a:pPr>
-              <a:t>9/30/2026</a:t>
+              <a:t>10/4/2026</a:t>
             </a:fld>
             <a:endParaRPr kumimoji="0" lang="en-US" sz="1200" b="0" i="0" u="none" strike="noStrike" kern="1200" cap="none" spc="0" normalizeH="0" baseline="0" noProof="0">
               <a:ln>
@@ -5725,7 +5743,7 @@
                 <a:tabLst/>
                 <a:defRPr/>
               </a:pPr>
-              <a:t>9/30/2026</a:t>
+              <a:t>10/4/2026</a:t>
             </a:fld>
             <a:endParaRPr kumimoji="0" lang="en-US" sz="1200" b="0" i="0" u="none" strike="noStrike" kern="1200" cap="none" spc="0" normalizeH="0" baseline="0" noProof="0">
               <a:ln>
@@ -6695,7 +6713,7 @@
                 <a:tabLst/>
                 <a:defRPr/>
               </a:pPr>
-              <a:t>9/30/2026</a:t>
+              <a:t>10/4/2026</a:t>
             </a:fld>
             <a:endParaRPr kumimoji="0" lang="en-US" sz="1200" b="0" i="0" u="none" strike="noStrike" kern="1200" cap="none" spc="0" normalizeH="0" baseline="0" noProof="0">
               <a:ln>
@@ -7121,7 +7139,7 @@
                 <a:tabLst/>
                 <a:defRPr/>
               </a:pPr>
-              <a:t>9/30/2026</a:t>
+              <a:t>10/4/2026</a:t>
             </a:fld>
             <a:endParaRPr kumimoji="0" lang="en-US" sz="1200" b="0" i="0" u="none" strike="noStrike" kern="1200" cap="none" spc="0" normalizeH="0" baseline="0" noProof="0">
               <a:ln>
@@ -7485,7 +7503,7 @@
                 <a:tabLst/>
                 <a:defRPr/>
               </a:pPr>
-              <a:t>9/30/2026</a:t>
+              <a:t>10/4/2026</a:t>
             </a:fld>
             <a:endParaRPr kumimoji="0" lang="en-US" sz="1200" b="0" i="0" u="none" strike="noStrike" kern="1200" cap="none" spc="0" normalizeH="0" baseline="0" noProof="0">
               <a:ln>
@@ -8012,7 +8030,7 @@
                 <a:tabLst/>
                 <a:defRPr/>
               </a:pPr>
-              <a:t>9/30/2026</a:t>
+              <a:t>10/4/2026</a:t>
             </a:fld>
             <a:endParaRPr kumimoji="0" lang="en-US" sz="1200" b="0" i="0" u="none" strike="noStrike" kern="1200" cap="none" spc="0" normalizeH="0" baseline="0" noProof="0">
               <a:ln>
@@ -8473,7 +8491,7 @@
                 <a:tabLst/>
                 <a:defRPr/>
               </a:pPr>
-              <a:t>9/30/2026</a:t>
+              <a:t>10/4/2026</a:t>
             </a:fld>
             <a:endParaRPr kumimoji="0" lang="en-US" sz="1200" b="0" i="0" u="none" strike="noStrike" kern="1200" cap="none" spc="0" normalizeH="0" baseline="0" noProof="0">
               <a:ln>
@@ -9081,7 +9099,7 @@
                 <a:tabLst/>
                 <a:defRPr/>
               </a:pPr>
-              <a:t>9/30/2026</a:t>
+              <a:t>10/4/2026</a:t>
             </a:fld>
             <a:endParaRPr kumimoji="0" lang="en-US" sz="1200" b="0" i="0" u="none" strike="noStrike" kern="1200" cap="none" spc="0" normalizeH="0" baseline="0" noProof="0">
               <a:ln>
@@ -9354,7 +9372,7 @@
                 <a:tabLst/>
                 <a:defRPr/>
               </a:pPr>
-              <a:t>9/30/2026</a:t>
+              <a:t>10/4/2026</a:t>
             </a:fld>
             <a:endParaRPr kumimoji="0" lang="en-US" sz="1200" b="0" i="0" u="none" strike="noStrike" kern="1200" cap="none" spc="0" normalizeH="0" baseline="0" noProof="0">
               <a:ln>
@@ -9825,7 +9843,7 @@
                 <a:tabLst/>
                 <a:defRPr/>
               </a:pPr>
-              <a:t>9/30/2026</a:t>
+              <a:t>10/4/2026</a:t>
             </a:fld>
             <a:endParaRPr kumimoji="0" lang="en-US" sz="1200" b="0" i="0" u="none" strike="noStrike" kern="1200" cap="none" spc="0" normalizeH="0" baseline="0" noProof="0">
               <a:ln>
@@ -10226,7 +10244,7 @@
                 <a:tabLst/>
                 <a:defRPr/>
               </a:pPr>
-              <a:t>9/30/2026</a:t>
+              <a:t>10/4/2026</a:t>
             </a:fld>
             <a:endParaRPr kumimoji="0" lang="en-US" sz="1200" b="0" i="0" u="none" strike="noStrike" kern="1200" cap="none" spc="0" normalizeH="0" baseline="0" noProof="0">
               <a:ln>
@@ -12330,13 +12348,29 @@
           <a:p>
             <a:r>
               <a:rPr lang="en-US" dirty="0"/>
-              <a:t>In JS, you work on one and one task only (i.e., event loop has a single call stack)</a:t>
-            </a:r>
-          </a:p>
-          <a:p>
+              <a:t>In JS, you work on </a:t>
+            </a:r>
+            <a:r>
+              <a:rPr lang="en-US" b="1" dirty="0"/>
+              <a:t>one and one task only</a:t>
+            </a:r>
             <a:r>
               <a:rPr lang="en-US" dirty="0"/>
-              <a:t>Also, if you start a task, you must finish it (i.e., call stack must be emptied) before you start another task. This pattern is called "run-to-completion" semantics</a:t>
+              <a:t> (i.e., event loop has a single call stack)</a:t>
+            </a:r>
+          </a:p>
+          <a:p>
+            <a:r>
+              <a:rPr lang="en-US" dirty="0"/>
+              <a:t>Also, if you start a task, you </a:t>
+            </a:r>
+            <a:r>
+              <a:rPr lang="en-US" b="1" dirty="0"/>
+              <a:t>must </a:t>
+            </a:r>
+            <a:r>
+              <a:rPr lang="en-US" dirty="0"/>
+              <a:t>finish it (i.e., call stack must be emptied) before you start another task. This pattern is called "run-to-completion" semantics</a:t>
             </a:r>
           </a:p>
           <a:p>
@@ -12349,7 +12383,11 @@
             <a:pPr lvl="1"/>
             <a:r>
               <a:rPr lang="en-US" dirty="0"/>
-              <a:t>when it reaches an await</a:t>
+              <a:t>when it reaches an </a:t>
+            </a:r>
+            <a:r>
+              <a:rPr lang="en-US" b="1" dirty="0"/>
+              <a:t>await</a:t>
             </a:r>
           </a:p>
           <a:p>
@@ -12454,6 +12492,36 @@
           </a:p>
         </p:txBody>
       </p:sp>
+      <p:pic>
+        <p:nvPicPr>
+          <p:cNvPr id="6" name="Picture 5" descr="a&#10;&#10;AI-generated content may be incorrect.">
+            <a:extLst>
+              <a:ext uri="{FF2B5EF4-FFF2-40B4-BE49-F238E27FC236}">
+                <a16:creationId xmlns:a16="http://schemas.microsoft.com/office/drawing/2014/main" id="{81F5B03E-34AA-D87B-8D3C-398C901AA0C4}"/>
+              </a:ext>
+            </a:extLst>
+          </p:cNvPr>
+          <p:cNvPicPr>
+            <a:picLocks noChangeAspect="1"/>
+          </p:cNvPicPr>
+          <p:nvPr/>
+        </p:nvPicPr>
+        <p:blipFill>
+          <a:blip r:embed="rId3"/>
+          <a:stretch>
+            <a:fillRect/>
+          </a:stretch>
+        </p:blipFill>
+        <p:spPr>
+          <a:xfrm>
+            <a:off x="8850888" y="1531097"/>
+            <a:ext cx="2262624" cy="3795806"/>
+          </a:xfrm>
+          <a:prstGeom prst="rect">
+            <a:avLst/>
+          </a:prstGeom>
+        </p:spPr>
+      </p:pic>
     </p:spTree>
     <p:extLst>
       <p:ext uri="{BB962C8B-B14F-4D97-AF65-F5344CB8AC3E}">
@@ -15069,7 +15137,7 @@
           <a:p>
             <a:r>
               <a:rPr lang="en-US" dirty="0"/>
-              <a:t>One Event Loop means that we have single thread of execution</a:t>
+              <a:t>Event Loop with one Call Stack means that we have single thread of execution</a:t>
             </a:r>
           </a:p>
           <a:p>
@@ -25448,7 +25516,7 @@
                 <a:effectLst/>
                 <a:latin typeface="Consolas" panose="020B0609020204030204" pitchFamily="49" charset="0"/>
               </a:rPr>
-              <a:t>2</a:t>
+              <a:t>3</a:t>
             </a:r>
             <a:r>
               <a:rPr lang="en-US" sz="2000" b="0" dirty="0">
@@ -25503,7 +25571,7 @@
                 <a:effectLst/>
                 <a:latin typeface="Consolas" panose="020B0609020204030204" pitchFamily="49" charset="0"/>
               </a:rPr>
-              <a:t>(2) returned: </a:t>
+              <a:t>(3) returned: </a:t>
             </a:r>
             <a:r>
               <a:rPr lang="en-US" sz="2000" b="0" dirty="0">
@@ -45286,7 +45354,7 @@
             </a:pPr>
             <a:r>
               <a:rPr lang="en-US" sz="1800" dirty="0"/>
-              <a:t>These are things like http requests, I/O operations, or timers.</a:t>
+              <a:t>These are things like http requests, I/O operations, or timers</a:t>
             </a:r>
           </a:p>
           <a:p>

</xml_diff>